<commit_message>
Tira a analise de despesas do projeto de logistica
As despesas sao de outro projeto, nao deste sistema.

- carga_inicial_despesas.sql saiu da pasta (foi para OneDrive\Documentos,
  junto do Excel de origem).
- supabase-setup.sql: removido o bloco MODULO DESPESAS (tabelas despesas,
  despesas_faturamento e metas). Ficaram as 7 tabelas de logistica. O bloco
  foi preservado em OneDrive\Documentos\supabase-despesas.sql.
- Documentacao, apresentacao e roteiro: retiradas as mencoes ao modulo de
  Despesas como proximo passo deste sistema.

Co-Authored-By: Claude Opus 5 <noreply@anthropic.com>
</commit_message>
<xml_diff>
--- a/Apresentacao_Sistema_Gestao_Logistica.pptx
+++ b/Apresentacao_Sistema_Gestao_Logistica.pptx
@@ -21,10 +21,9 @@
     <p:sldId id="269" r:id="rId15"/>
     <p:sldId id="270" r:id="rId16"/>
     <p:sldId id="271" r:id="rId17"/>
-    <p:sldId id="272" r:id="rId18"/>
   </p:sldIdLst>
   <p:notesMasterIdLst>
-    <p:notesMasterId r:id="rId19"/>
+    <p:notesMasterId r:id="rId18"/>
   </p:notesMasterIdLst>
   <p:sldSz cx="12188952" cy="6858000"/>
   <p:notesSz cx="6858000" cy="12188952"/>
@@ -1158,94 +1157,6 @@
             <a:fld id="{F7021451-1387-4CA6-816F-3879F97B5CBC}" type="slidenum">
               <a:rPr lang="en-US"/>
               <a:t>16</a:t>
-            </a:fld>
-            <a:endParaRPr lang="en-US"/>
-          </a:p>
-        </p:txBody>
-      </p:sp>
-    </p:spTree>
-    <p:extLst>
-      <p:ext uri="{BB962C8B-B14F-4D97-AF65-F5344CB8AC3E}">
-        <p14:creationId xmlns:p14="http://schemas.microsoft.com/office/powerpoint/2010/main" val="1024086991"/>
-      </p:ext>
-    </p:extLst>
-  </p:cSld>
-  <p:clrMapOvr>
-    <a:masterClrMapping/>
-  </p:clrMapOvr>
-</p:notes>
-</file>
-
-<file path=ppt/notesSlides/notesSlide17.xml><?xml version="1.0" encoding="utf-8"?>
-<p:notes xmlns:a="http://schemas.openxmlformats.org/drawingml/2006/main" xmlns:r="http://schemas.openxmlformats.org/officeDocument/2006/relationships" xmlns:p="http://schemas.openxmlformats.org/presentationml/2006/main">
-  <p:cSld>
-    <p:spTree>
-      <p:nvGrpSpPr>
-        <p:cNvPr id="1" name=""/>
-        <p:cNvGrpSpPr/>
-        <p:nvPr/>
-      </p:nvGrpSpPr>
-      <p:grpSpPr>
-        <a:xfrm>
-          <a:off x="0" y="0"/>
-          <a:ext cx="0" cy="0"/>
-          <a:chOff x="0" y="0"/>
-          <a:chExt cx="0" cy="0"/>
-        </a:xfrm>
-      </p:grpSpPr>
-      <p:sp>
-        <p:nvSpPr>
-          <p:cNvPr id="2" name="Slide Image Placeholder 1"/>
-          <p:cNvSpPr>
-            <a:spLocks noGrp="1" noRot="1" noChangeAspect="1"/>
-          </p:cNvSpPr>
-          <p:nvPr>
-            <p:ph type="sldImg"/>
-          </p:nvPr>
-        </p:nvSpPr>
-        <p:spPr/>
-      </p:sp>
-      <p:sp>
-        <p:nvSpPr>
-          <p:cNvPr id="3" name="Notes Placeholder 2"/>
-          <p:cNvSpPr>
-            <a:spLocks noGrp="1"/>
-          </p:cNvSpPr>
-          <p:nvPr>
-            <p:ph type="body" idx="1"/>
-          </p:nvPr>
-        </p:nvSpPr>
-        <p:spPr/>
-        <p:txBody>
-          <a:bodyPr/>
-          <a:lstStyle/>
-          <a:p>
-            <a:r>
-              <a:rPr lang="en-US" dirty="0"/>
-              <a:t/>
-            </a:r>
-            <a:endParaRPr lang="en-US" dirty="0"/>
-          </a:p>
-        </p:txBody>
-      </p:sp>
-      <p:sp>
-        <p:nvSpPr>
-          <p:cNvPr id="4" name="Slide Number Placeholder 3"/>
-          <p:cNvSpPr>
-            <a:spLocks noGrp="1"/>
-          </p:cNvSpPr>
-          <p:nvPr>
-            <p:ph type="sldNum" sz="quarter" idx="10"/>
-          </p:nvPr>
-        </p:nvSpPr>
-        <p:spPr/>
-        <p:txBody>
-          <a:bodyPr/>
-          <a:lstStyle/>
-          <a:p>
-            <a:fld id="{F7021451-1387-4CA6-816F-3879F97B5CBC}" type="slidenum">
-              <a:rPr lang="en-US"/>
-              <a:t>17</a:t>
             </a:fld>
             <a:endParaRPr lang="en-US"/>
           </a:p>
@@ -5548,340 +5459,6 @@
     <p:bg>
       <p:bgPr>
         <a:solidFill>
-          <a:srgbClr val="FFFFFF"/>
-        </a:solidFill>
-      </p:bgPr>
-    </p:bg>
-    <p:spTree>
-      <p:nvGrpSpPr>
-        <p:cNvPr id="1" name=""/>
-        <p:cNvGrpSpPr/>
-        <p:nvPr/>
-      </p:nvGrpSpPr>
-      <p:grpSpPr>
-        <a:xfrm>
-          <a:off x="0" y="0"/>
-          <a:ext cx="0" cy="0"/>
-          <a:chOff x="0" y="0"/>
-          <a:chExt cx="0" cy="0"/>
-        </a:xfrm>
-      </p:grpSpPr>
-      <p:sp>
-        <p:nvSpPr>
-          <p:cNvPr id="2" name="Shape 0"/>
-          <p:cNvSpPr/>
-          <p:nvPr/>
-        </p:nvSpPr>
-        <p:spPr>
-          <a:xfrm>
-            <a:off x="0" y="0"/>
-            <a:ext cx="201168" cy="6858000"/>
-          </a:xfrm>
-          <a:prstGeom prst="rect">
-            <a:avLst/>
-          </a:prstGeom>
-          <a:solidFill>
-            <a:srgbClr val="14315B"/>
-          </a:solidFill>
-          <a:ln/>
-        </p:spPr>
-      </p:sp>
-      <p:sp>
-        <p:nvSpPr>
-          <p:cNvPr id="3" name="Shape 1"/>
-          <p:cNvSpPr/>
-          <p:nvPr/>
-        </p:nvSpPr>
-        <p:spPr>
-          <a:xfrm>
-            <a:off x="201168" y="0"/>
-            <a:ext cx="54864" cy="6858000"/>
-          </a:xfrm>
-          <a:prstGeom prst="rect">
-            <a:avLst/>
-          </a:prstGeom>
-          <a:solidFill>
-            <a:srgbClr val="D9A420"/>
-          </a:solidFill>
-          <a:ln/>
-        </p:spPr>
-      </p:sp>
-      <p:sp>
-        <p:nvSpPr>
-          <p:cNvPr id="4" name="Text 2"/>
-          <p:cNvSpPr/>
-          <p:nvPr/>
-        </p:nvSpPr>
-        <p:spPr>
-          <a:xfrm>
-            <a:off x="594360" y="320040"/>
-            <a:ext cx="7315200" cy="365760"/>
-          </a:xfrm>
-          <a:prstGeom prst="rect">
-            <a:avLst/>
-          </a:prstGeom>
-          <a:noFill/>
-          <a:ln/>
-        </p:spPr>
-        <p:txBody>
-          <a:bodyPr wrap="square" rtlCol="0" anchor="ctr"/>
-          <a:lstStyle/>
-          <a:p>
-            <a:pPr indent="0" marL="0">
-              <a:buNone/>
-            </a:pPr>
-            <a:r>
-              <a:rPr lang="en-US" sz="1300" b="1" spc="200" kern="0" dirty="0">
-                <a:solidFill>
-                  <a:srgbClr val="D9A420"/>
-                </a:solidFill>
-                <a:latin typeface="Calibri" pitchFamily="34" charset="0"/>
-                <a:ea typeface="Calibri" pitchFamily="34" charset="-122"/>
-                <a:cs typeface="Calibri" pitchFamily="34" charset="-120"/>
-              </a:rPr>
-              <a:t>PRÓXIMOS PASSOS</a:t>
-            </a:r>
-            <a:endParaRPr lang="en-US" sz="1300" dirty="0"/>
-          </a:p>
-        </p:txBody>
-      </p:sp>
-      <p:sp>
-        <p:nvSpPr>
-          <p:cNvPr id="5" name="Text 3"/>
-          <p:cNvSpPr/>
-          <p:nvPr/>
-        </p:nvSpPr>
-        <p:spPr>
-          <a:xfrm>
-            <a:off x="7616952" y="6400800"/>
-            <a:ext cx="4297680" cy="274320"/>
-          </a:xfrm>
-          <a:prstGeom prst="rect">
-            <a:avLst/>
-          </a:prstGeom>
-          <a:noFill/>
-          <a:ln/>
-        </p:spPr>
-        <p:txBody>
-          <a:bodyPr wrap="square" rtlCol="0" anchor="ctr"/>
-          <a:lstStyle/>
-          <a:p>
-            <a:pPr algn="r" indent="0" marL="0">
-              <a:buNone/>
-            </a:pPr>
-            <a:r>
-              <a:rPr lang="en-US" sz="900" dirty="0">
-                <a:solidFill>
-                  <a:srgbClr val="5B6472"/>
-                </a:solidFill>
-                <a:latin typeface="Calibri" pitchFamily="34" charset="0"/>
-                <a:ea typeface="Calibri" pitchFamily="34" charset="-122"/>
-                <a:cs typeface="Calibri" pitchFamily="34" charset="-120"/>
-              </a:rPr>
-              <a:t>DILNOR · GESTÃO LOGÍSTICA</a:t>
-            </a:r>
-            <a:endParaRPr lang="en-US" sz="900" dirty="0"/>
-          </a:p>
-        </p:txBody>
-      </p:sp>
-      <p:sp>
-        <p:nvSpPr>
-          <p:cNvPr id="6" name="Text 4"/>
-          <p:cNvSpPr/>
-          <p:nvPr/>
-        </p:nvSpPr>
-        <p:spPr>
-          <a:xfrm>
-            <a:off x="594360" y="868680"/>
-            <a:ext cx="10789920" cy="1005840"/>
-          </a:xfrm>
-          <a:prstGeom prst="rect">
-            <a:avLst/>
-          </a:prstGeom>
-          <a:noFill/>
-          <a:ln/>
-        </p:spPr>
-        <p:txBody>
-          <a:bodyPr wrap="square" rtlCol="0" anchor="ctr"/>
-          <a:lstStyle/>
-          <a:p>
-            <a:pPr indent="0" marL="0">
-              <a:buNone/>
-            </a:pPr>
-            <a:r>
-              <a:rPr lang="en-US" sz="3400" b="1" dirty="0">
-                <a:solidFill>
-                  <a:srgbClr val="14315B"/>
-                </a:solidFill>
-                <a:latin typeface="Calibri" pitchFamily="34" charset="0"/>
-                <a:ea typeface="Calibri" pitchFamily="34" charset="-122"/>
-                <a:cs typeface="Calibri" pitchFamily="34" charset="-120"/>
-              </a:rPr>
-              <a:t>Módulo de Despesas</a:t>
-            </a:r>
-            <a:endParaRPr lang="en-US" sz="3400" dirty="0"/>
-          </a:p>
-        </p:txBody>
-      </p:sp>
-      <p:sp>
-        <p:nvSpPr>
-          <p:cNvPr id="7" name="Text 5"/>
-          <p:cNvSpPr/>
-          <p:nvPr/>
-        </p:nvSpPr>
-        <p:spPr>
-          <a:xfrm>
-            <a:off x="594360" y="1691640"/>
-            <a:ext cx="10607040" cy="548640"/>
-          </a:xfrm>
-          <a:prstGeom prst="rect">
-            <a:avLst/>
-          </a:prstGeom>
-          <a:noFill/>
-          <a:ln/>
-        </p:spPr>
-        <p:txBody>
-          <a:bodyPr wrap="square" rtlCol="0" anchor="ctr"/>
-          <a:lstStyle/>
-          <a:p>
-            <a:pPr indent="0" marL="0">
-              <a:buNone/>
-            </a:pPr>
-            <a:r>
-              <a:rPr lang="en-US" sz="1600" dirty="0">
-                <a:solidFill>
-                  <a:srgbClr val="5B6472"/>
-                </a:solidFill>
-                <a:latin typeface="Calibri" pitchFamily="34" charset="0"/>
-                <a:ea typeface="Calibri" pitchFamily="34" charset="-122"/>
-                <a:cs typeface="Calibri" pitchFamily="34" charset="-120"/>
-              </a:rPr>
-              <a:t>A base de dados já está pronta — falta apenas construir a tela.</a:t>
-            </a:r>
-            <a:endParaRPr lang="en-US" sz="1600" dirty="0"/>
-          </a:p>
-        </p:txBody>
-      </p:sp>
-      <p:sp>
-        <p:nvSpPr>
-          <p:cNvPr id="8" name="Shape 6"/>
-          <p:cNvSpPr/>
-          <p:nvPr/>
-        </p:nvSpPr>
-        <p:spPr>
-          <a:xfrm>
-            <a:off x="594360" y="2468880"/>
-            <a:ext cx="10607040" cy="1188720"/>
-          </a:xfrm>
-          <a:prstGeom prst="roundRect">
-            <a:avLst>
-              <a:gd name="adj" fmla="val 6154"/>
-            </a:avLst>
-          </a:prstGeom>
-          <a:solidFill>
-            <a:srgbClr val="F6E4B0"/>
-          </a:solidFill>
-          <a:ln/>
-        </p:spPr>
-      </p:sp>
-      <p:sp>
-        <p:nvSpPr>
-          <p:cNvPr id="9" name="Text 7"/>
-          <p:cNvSpPr/>
-          <p:nvPr/>
-        </p:nvSpPr>
-        <p:spPr>
-          <a:xfrm>
-            <a:off x="914400" y="2468880"/>
-            <a:ext cx="10058400" cy="1188720"/>
-          </a:xfrm>
-          <a:prstGeom prst="rect">
-            <a:avLst/>
-          </a:prstGeom>
-          <a:noFill/>
-          <a:ln/>
-        </p:spPr>
-        <p:txBody>
-          <a:bodyPr wrap="square" rtlCol="0" anchor="ctr"/>
-          <a:lstStyle/>
-          <a:p>
-            <a:pPr indent="0" marL="0">
-              <a:lnSpc>
-                <a:spcPts val="2200"/>
-              </a:lnSpc>
-              <a:buNone/>
-            </a:pPr>
-            <a:r>
-              <a:rPr lang="en-US" sz="1600" b="1" dirty="0">
-                <a:solidFill>
-                  <a:srgbClr val="0C223F"/>
-                </a:solidFill>
-                <a:latin typeface="Calibri" pitchFamily="34" charset="0"/>
-                <a:ea typeface="Calibri" pitchFamily="34" charset="-122"/>
-                <a:cs typeface="Calibri" pitchFamily="34" charset="-120"/>
-              </a:rPr>
-              <a:t>3.419 registros históricos da Dilnor (2022–2026) já foram carregados no banco — aluguel, salários e demais contas do balancete mensal.</a:t>
-            </a:r>
-            <a:endParaRPr lang="en-US" sz="1600" dirty="0"/>
-          </a:p>
-        </p:txBody>
-      </p:sp>
-      <p:sp>
-        <p:nvSpPr>
-          <p:cNvPr id="10" name="Text 8"/>
-          <p:cNvSpPr/>
-          <p:nvPr/>
-        </p:nvSpPr>
-        <p:spPr>
-          <a:xfrm>
-            <a:off x="594360" y="3931920"/>
-            <a:ext cx="10607040" cy="1005840"/>
-          </a:xfrm>
-          <a:prstGeom prst="rect">
-            <a:avLst/>
-          </a:prstGeom>
-          <a:noFill/>
-          <a:ln/>
-        </p:spPr>
-        <p:txBody>
-          <a:bodyPr wrap="square" rtlCol="0" anchor="ctr"/>
-          <a:lstStyle/>
-          <a:p>
-            <a:pPr indent="0" marL="0">
-              <a:lnSpc>
-                <a:spcPts val="2200"/>
-              </a:lnSpc>
-              <a:buNone/>
-            </a:pPr>
-            <a:r>
-              <a:rPr lang="en-US" sz="1500" dirty="0">
-                <a:solidFill>
-                  <a:srgbClr val="242833"/>
-                </a:solidFill>
-                <a:latin typeface="Calibri" pitchFamily="34" charset="0"/>
-                <a:ea typeface="Calibri" pitchFamily="34" charset="-122"/>
-                <a:cs typeface="Calibri" pitchFamily="34" charset="-120"/>
-              </a:rPr>
-              <a:t>Quando concluído, o módulo vai comparar, mês a mês, o que foi gasto contra o que foi orçado (meta), por grupo de conta — visão que hoje depende de cruzar planilhas manualmente.</a:t>
-            </a:r>
-            <a:endParaRPr lang="en-US" sz="1500" dirty="0"/>
-          </a:p>
-        </p:txBody>
-      </p:sp>
-    </p:spTree>
-  </p:cSld>
-  <p:clrMapOvr>
-    <a:masterClrMapping/>
-  </p:clrMapOvr>
-</p:sld>
-</file>
-
-<file path=ppt/slides/slide17.xml><?xml version="1.0" encoding="utf-8"?>
-<p:sld xmlns:a="http://schemas.openxmlformats.org/drawingml/2006/main" xmlns:r="http://schemas.openxmlformats.org/officeDocument/2006/relationships" xmlns:p="http://schemas.openxmlformats.org/presentationml/2006/main">
-  <p:cSld name="Slide 17">
-    <p:bg>
-      <p:bgPr>
-        <a:solidFill>
           <a:srgbClr val="14315B"/>
         </a:solidFill>
       </p:bgPr>

</xml_diff>